<commit_message>
Presentation final crlk ja chega desta merda pqp
</commit_message>
<xml_diff>
--- a/FixNPresent_v2 .pptx
+++ b/FixNPresent_v2 .pptx
@@ -2131,7 +2131,106 @@
                 <a:ea typeface="Calibri" pitchFamily="34" charset="-122"/>
                 <a:cs typeface="Calibri" pitchFamily="34" charset="-120"/>
               </a:rPr>
-              <a:t>Sistema de Gestão Integrada para Oficina de Micromobilidade</a:t>
+              <a:t>Sistema de </a:t>
+            </a:r>
+            <a:r>
+              <a:rPr lang="en-US" sz="1700" dirty="0" err="1">
+                <a:solidFill>
+                  <a:srgbClr val="0EA5E9"/>
+                </a:solidFill>
+                <a:latin typeface="Calibri" pitchFamily="34" charset="0"/>
+                <a:ea typeface="Calibri" pitchFamily="34" charset="-122"/>
+                <a:cs typeface="Calibri" pitchFamily="34" charset="-120"/>
+              </a:rPr>
+              <a:t>Gestão</a:t>
+            </a:r>
+            <a:r>
+              <a:rPr lang="en-US" sz="1700" dirty="0">
+                <a:solidFill>
+                  <a:srgbClr val="0EA5E9"/>
+                </a:solidFill>
+                <a:latin typeface="Calibri" pitchFamily="34" charset="0"/>
+                <a:ea typeface="Calibri" pitchFamily="34" charset="-122"/>
+                <a:cs typeface="Calibri" pitchFamily="34" charset="-120"/>
+              </a:rPr>
+              <a:t> para </a:t>
+            </a:r>
+            <a:r>
+              <a:rPr lang="en-US" sz="1700" dirty="0" err="1">
+                <a:solidFill>
+                  <a:srgbClr val="0EA5E9"/>
+                </a:solidFill>
+                <a:latin typeface="Calibri" pitchFamily="34" charset="0"/>
+                <a:ea typeface="Calibri" pitchFamily="34" charset="-122"/>
+                <a:cs typeface="Calibri" pitchFamily="34" charset="-120"/>
+              </a:rPr>
+              <a:t>uma</a:t>
+            </a:r>
+            <a:r>
+              <a:rPr lang="en-US" sz="1700" dirty="0">
+                <a:solidFill>
+                  <a:srgbClr val="0EA5E9"/>
+                </a:solidFill>
+                <a:latin typeface="Calibri" pitchFamily="34" charset="0"/>
+                <a:ea typeface="Calibri" pitchFamily="34" charset="-122"/>
+                <a:cs typeface="Calibri" pitchFamily="34" charset="-120"/>
+              </a:rPr>
+              <a:t> </a:t>
+            </a:r>
+            <a:r>
+              <a:rPr lang="en-US" sz="1700" dirty="0" err="1">
+                <a:solidFill>
+                  <a:srgbClr val="0EA5E9"/>
+                </a:solidFill>
+                <a:latin typeface="Calibri" pitchFamily="34" charset="0"/>
+                <a:ea typeface="Calibri" pitchFamily="34" charset="-122"/>
+                <a:cs typeface="Calibri" pitchFamily="34" charset="-120"/>
+              </a:rPr>
+              <a:t>Oficina</a:t>
+            </a:r>
+            <a:r>
+              <a:rPr lang="en-US" sz="1700" dirty="0">
+                <a:solidFill>
+                  <a:srgbClr val="0EA5E9"/>
+                </a:solidFill>
+                <a:latin typeface="Calibri" pitchFamily="34" charset="0"/>
+                <a:ea typeface="Calibri" pitchFamily="34" charset="-122"/>
+                <a:cs typeface="Calibri" pitchFamily="34" charset="-120"/>
+              </a:rPr>
+              <a:t> de </a:t>
+            </a:r>
+            <a:r>
+              <a:rPr lang="en-US" sz="1700" dirty="0" err="1">
+                <a:solidFill>
+                  <a:srgbClr val="0EA5E9"/>
+                </a:solidFill>
+                <a:latin typeface="Calibri" pitchFamily="34" charset="0"/>
+                <a:ea typeface="Calibri" pitchFamily="34" charset="-122"/>
+                <a:cs typeface="Calibri" pitchFamily="34" charset="-120"/>
+              </a:rPr>
+              <a:t>Reparação</a:t>
+            </a:r>
+            <a:r>
+              <a:rPr lang="en-US" sz="1700" dirty="0">
+                <a:solidFill>
+                  <a:srgbClr val="0EA5E9"/>
+                </a:solidFill>
+                <a:latin typeface="Calibri" pitchFamily="34" charset="0"/>
+                <a:ea typeface="Calibri" pitchFamily="34" charset="-122"/>
+                <a:cs typeface="Calibri" pitchFamily="34" charset="-120"/>
+              </a:rPr>
+              <a:t> de </a:t>
+            </a:r>
+            <a:r>
+              <a:rPr lang="en-US" sz="1700" dirty="0" err="1">
+                <a:solidFill>
+                  <a:srgbClr val="0EA5E9"/>
+                </a:solidFill>
+                <a:latin typeface="Calibri" pitchFamily="34" charset="0"/>
+                <a:ea typeface="Calibri" pitchFamily="34" charset="-122"/>
+                <a:cs typeface="Calibri" pitchFamily="34" charset="-120"/>
+              </a:rPr>
+              <a:t>Trotinetes</a:t>
             </a:r>
             <a:endParaRPr lang="en-US" sz="1700" dirty="0"/>
           </a:p>
@@ -2277,6 +2376,124 @@
           <a:lstStyle/>
           <a:p>
             <a:endParaRPr lang="en-US"/>
+          </a:p>
+        </p:txBody>
+      </p:sp>
+      <p:sp>
+        <p:nvSpPr>
+          <p:cNvPr id="10" name="Rectangle 1">
+            <a:extLst>
+              <a:ext uri="{FF2B5EF4-FFF2-40B4-BE49-F238E27FC236}">
+                <a16:creationId xmlns:a16="http://schemas.microsoft.com/office/drawing/2014/main" id="{7FE90460-9FE7-5B8E-CA45-5DFFE0736A55}"/>
+              </a:ext>
+            </a:extLst>
+          </p:cNvPr>
+          <p:cNvSpPr>
+            <a:spLocks noChangeArrowheads="1"/>
+          </p:cNvSpPr>
+          <p:nvPr/>
+        </p:nvSpPr>
+        <p:spPr bwMode="auto">
+          <a:xfrm>
+            <a:off x="0" y="0"/>
+            <a:ext cx="9144000" cy="0"/>
+          </a:xfrm>
+          <a:prstGeom prst="rect">
+            <a:avLst/>
+          </a:prstGeom>
+          <a:noFill/>
+          <a:ln>
+            <a:noFill/>
+          </a:ln>
+          <a:effectLst/>
+          <a:extLst>
+            <a:ext uri="{909E8E84-426E-40DD-AFC4-6F175D3DCCD1}">
+              <a14:hiddenFill xmlns:a14="http://schemas.microsoft.com/office/drawing/2010/main">
+                <a:solidFill>
+                  <a:schemeClr val="accent1"/>
+                </a:solidFill>
+              </a14:hiddenFill>
+            </a:ext>
+            <a:ext uri="{91240B29-F687-4F45-9708-019B960494DF}">
+              <a14:hiddenLine xmlns:a14="http://schemas.microsoft.com/office/drawing/2010/main" w="9525">
+                <a:solidFill>
+                  <a:schemeClr val="tx1"/>
+                </a:solidFill>
+                <a:miter lim="800000"/>
+                <a:headEnd/>
+                <a:tailEnd/>
+              </a14:hiddenLine>
+            </a:ext>
+            <a:ext uri="{AF507438-7753-43E0-B8FC-AC1667EBCBE1}">
+              <a14:hiddenEffects xmlns:a14="http://schemas.microsoft.com/office/drawing/2010/main">
+                <a:effectLst>
+                  <a:outerShdw dist="35921" dir="2700000" algn="ctr" rotWithShape="0">
+                    <a:schemeClr val="bg2"/>
+                  </a:outerShdw>
+                </a:effectLst>
+              </a14:hiddenEffects>
+            </a:ext>
+          </a:extLst>
+        </p:spPr>
+        <p:txBody>
+          <a:bodyPr vert="horz" wrap="none" lIns="91440" tIns="45720" rIns="91440" bIns="45720" numCol="1" anchor="ctr" anchorCtr="0" compatLnSpc="1">
+            <a:prstTxWarp prst="textNoShape">
+              <a:avLst/>
+            </a:prstTxWarp>
+            <a:spAutoFit/>
+          </a:bodyPr>
+          <a:lstStyle/>
+          <a:p>
+            <a:pPr marL="0" marR="0" lvl="0" indent="0" algn="l" defTabSz="914400" rtl="0" eaLnBrk="0" fontAlgn="base" latinLnBrk="0" hangingPunct="0">
+              <a:lnSpc>
+                <a:spcPct val="100000"/>
+              </a:lnSpc>
+              <a:spcBef>
+                <a:spcPct val="0"/>
+              </a:spcBef>
+              <a:spcAft>
+                <a:spcPct val="0"/>
+              </a:spcAft>
+              <a:buClrTx/>
+              <a:buSzTx/>
+              <a:buFontTx/>
+              <a:buNone/>
+              <a:tabLst/>
+            </a:pPr>
+            <a:r>
+              <a:rPr kumimoji="0" lang="en-US" altLang="en-US" sz="1800" b="0" i="0" u="none" strike="noStrike" cap="none" normalizeH="0" baseline="0">
+                <a:ln>
+                  <a:noFill/>
+                </a:ln>
+                <a:solidFill>
+                  <a:schemeClr val="tx1"/>
+                </a:solidFill>
+                <a:effectLst/>
+                <a:latin typeface="Times New Roman" panose="02020603050405020304" pitchFamily="18" charset="0"/>
+              </a:rPr>
+              <a:t>Sistema de gestão para uma oficina de reparação de trotinetes</a:t>
+            </a:r>
+            <a:br>
+              <a:rPr kumimoji="0" lang="en-US" altLang="en-US" sz="1800" b="0" i="0" u="none" strike="noStrike" cap="none" normalizeH="0" baseline="0">
+                <a:ln>
+                  <a:noFill/>
+                </a:ln>
+                <a:solidFill>
+                  <a:schemeClr val="tx1"/>
+                </a:solidFill>
+                <a:effectLst/>
+              </a:rPr>
+            </a:br>
+            <a:endParaRPr kumimoji="0" lang="en-US" altLang="en-US" sz="1800" b="0" i="0" u="none" strike="noStrike" cap="none" normalizeH="0" baseline="0">
+              <a:ln>
+                <a:noFill/>
+              </a:ln>
+              <a:solidFill>
+                <a:schemeClr val="tx1"/>
+              </a:solidFill>
+              <a:effectLst/>
+              <a:latin typeface="Arial" panose="020B0604020202020204" pitchFamily="34" charset="0"/>
+            </a:endParaRPr>
           </a:p>
         </p:txBody>
       </p:sp>

</xml_diff>